<commit_message>
docs: deck v2 — real product screenshots on slides 5, 8 and 10
</commit_message>
<xml_diff>
--- a/docs/precedent-deck.pptx
+++ b/docs/precedent-deck.pptx
@@ -3163,7 +3163,7 @@
           </a:bodyPr>
           <a:lstStyle/>
           <a:p>
-            <a:pPr algn="l">
+            <a:pPr>
               <a:lnSpc>
                 <a:spcPct val="100000"/>
               </a:lnSpc>
@@ -3202,7 +3202,7 @@
           </a:bodyPr>
           <a:lstStyle/>
           <a:p>
-            <a:pPr algn="l">
+            <a:pPr>
               <a:lnSpc>
                 <a:spcPct val="95000"/>
               </a:lnSpc>
@@ -3242,7 +3242,7 @@
           </a:bodyPr>
           <a:lstStyle/>
           <a:p>
-            <a:pPr algn="l">
+            <a:pPr>
               <a:lnSpc>
                 <a:spcPct val="100000"/>
               </a:lnSpc>
@@ -3281,7 +3281,7 @@
           </a:bodyPr>
           <a:lstStyle/>
           <a:p>
-            <a:pPr algn="l">
+            <a:pPr>
               <a:lnSpc>
                 <a:spcPct val="100000"/>
               </a:lnSpc>
@@ -3382,7 +3382,7 @@
           </a:bodyPr>
           <a:lstStyle/>
           <a:p>
-            <a:pPr algn="l">
+            <a:pPr>
               <a:lnSpc>
                 <a:spcPct val="100000"/>
               </a:lnSpc>
@@ -3421,13 +3421,13 @@
           </a:bodyPr>
           <a:lstStyle/>
           <a:p>
-            <a:pPr algn="l">
+            <a:pPr>
               <a:lnSpc>
                 <a:spcPct val="95000"/>
               </a:lnSpc>
             </a:pPr>
             <a:r>
-              <a:rPr sz="5400" b="1">
+              <a:rPr sz="4400" b="1">
                 <a:solidFill>
                   <a:srgbClr val="FFFFFF"/>
                 </a:solidFill>
@@ -3447,8 +3447,8 @@
         </p:nvSpPr>
         <p:spPr>
           <a:xfrm>
-            <a:off x="822960" y="3291840"/>
-            <a:ext cx="10515600" cy="3200400"/>
+            <a:off x="822960" y="3017520"/>
+            <a:ext cx="5669280" cy="2743200"/>
           </a:xfrm>
           <a:prstGeom prst="rect">
             <a:avLst/>
@@ -3461,81 +3461,105 @@
           </a:bodyPr>
           <a:lstStyle/>
           <a:p>
-            <a:pPr algn="l">
+            <a:pPr>
               <a:lnSpc>
                 <a:spcPct val="135000"/>
               </a:lnSpc>
             </a:pPr>
             <a:r>
-              <a:rPr sz="1900" b="0">
+              <a:rPr sz="1600" b="0">
                 <a:solidFill>
                   <a:srgbClr val="9AA0A6"/>
                 </a:solidFill>
                 <a:latin typeface="Barlow"/>
               </a:rPr>
-              <a:t>—  Buyer — the code owner auto-requested on every agent PR touching payments and auth</a:t>
-            </a:r>
-          </a:p>
-          <a:p>
-            <a:pPr algn="l">
+              <a:t>—  Buyer: the code owner on every agent PR touching payments/auth</a:t>
+            </a:r>
+          </a:p>
+          <a:p>
+            <a:pPr>
               <a:lnSpc>
                 <a:spcPct val="135000"/>
               </a:lnSpc>
             </a:pPr>
             <a:r>
-              <a:rPr sz="1900" b="0">
+              <a:rPr sz="1600" b="0">
                 <a:solidFill>
                   <a:srgbClr val="9AA0A6"/>
                 </a:solidFill>
                 <a:latin typeface="Barlow"/>
               </a:rPr>
-              <a:t>—  Wedge — one repo, one hook: precedent init</a:t>
-            </a:r>
-          </a:p>
-          <a:p>
-            <a:pPr algn="l">
+              <a:t>—  Wedge: one repo, one hook — precedent init</a:t>
+            </a:r>
+          </a:p>
+          <a:p>
+            <a:pPr>
               <a:lnSpc>
                 <a:spcPct val="135000"/>
               </a:lnSpc>
             </a:pPr>
             <a:r>
-              <a:rPr sz="1900" b="0">
+              <a:rPr sz="1600" b="0">
                 <a:solidFill>
                   <a:srgbClr val="9AA0A6"/>
                 </a:solidFill>
                 <a:latin typeface="Barlow"/>
               </a:rPr>
-              <a:t>—  Moat — rulings that compound; team memory that travels across agents</a:t>
-            </a:r>
-          </a:p>
-          <a:p>
-            <a:pPr algn="l">
+              <a:t>—  Moat: rulings that compound across agents and machines</a:t>
+            </a:r>
+          </a:p>
+          <a:p>
+            <a:pPr>
               <a:lnSpc>
                 <a:spcPct val="135000"/>
               </a:lnSpc>
             </a:pPr>
             <a:r>
-              <a:rPr sz="1900" b="0">
+              <a:rPr sz="1600" b="0">
                 <a:solidFill>
                   <a:srgbClr val="9AA0A6"/>
                 </a:solidFill>
                 <a:latin typeface="Barlow"/>
               </a:rPr>
-              <a:t>—  Framing — agents trustworthy enough for MORE autonomy, not less</a:t>
-            </a:r>
-          </a:p>
-        </p:txBody>
-      </p:sp>
-      <p:sp>
-        <p:nvSpPr>
-          <p:cNvPr id="6" name="TextBox 5"/>
+              <a:t>—  Agents trustworthy enough for MORE autonomy, not less</a:t>
+            </a:r>
+          </a:p>
+        </p:txBody>
+      </p:sp>
+      <p:pic>
+        <p:nvPicPr>
+          <p:cNvPr id="6" name="Picture 5" descr="landing.png"/>
+          <p:cNvPicPr>
+            <a:picLocks noChangeAspect="1"/>
+          </p:cNvPicPr>
+          <p:nvPr/>
+        </p:nvPicPr>
+        <p:blipFill>
+          <a:blip r:embed="rId2"/>
+          <a:stretch>
+            <a:fillRect/>
+          </a:stretch>
+        </p:blipFill>
+        <p:spPr>
+          <a:xfrm>
+            <a:off x="6766560" y="2377440"/>
+            <a:ext cx="4663440" cy="2914650"/>
+          </a:xfrm>
+          <a:prstGeom prst="rect">
+            <a:avLst/>
+          </a:prstGeom>
+        </p:spPr>
+      </p:pic>
+      <p:sp>
+        <p:nvSpPr>
+          <p:cNvPr id="7" name="TextBox 6"/>
           <p:cNvSpPr txBox="1"/>
           <p:nvPr/>
         </p:nvSpPr>
         <p:spPr>
           <a:xfrm>
-            <a:off x="822960" y="5943600"/>
-            <a:ext cx="10058400" cy="457200"/>
+            <a:off x="6766560" y="5346954"/>
+            <a:ext cx="4663440" cy="365760"/>
           </a:xfrm>
           <a:prstGeom prst="rect">
             <a:avLst/>
@@ -3548,19 +3572,58 @@
           </a:bodyPr>
           <a:lstStyle/>
           <a:p>
-            <a:pPr algn="l">
+            <a:pPr>
               <a:lnSpc>
                 <a:spcPct val="100000"/>
               </a:lnSpc>
             </a:pPr>
             <a:r>
+              <a:rPr sz="1100" b="0">
+                <a:solidFill>
+                  <a:srgbClr val="4A4F55"/>
+                </a:solidFill>
+                <a:latin typeface="Barlow"/>
+              </a:rPr>
+              <a:t>vnmoorthy.github.io/precedent</a:t>
+            </a:r>
+          </a:p>
+        </p:txBody>
+      </p:sp>
+      <p:sp>
+        <p:nvSpPr>
+          <p:cNvPr id="8" name="TextBox 7"/>
+          <p:cNvSpPr txBox="1"/>
+          <p:nvPr/>
+        </p:nvSpPr>
+        <p:spPr>
+          <a:xfrm>
+            <a:off x="822960" y="6035040"/>
+            <a:ext cx="10058400" cy="457200"/>
+          </a:xfrm>
+          <a:prstGeom prst="rect">
+            <a:avLst/>
+          </a:prstGeom>
+          <a:noFill/>
+        </p:spPr>
+        <p:txBody>
+          <a:bodyPr wrap="square">
+            <a:spAutoFit/>
+          </a:bodyPr>
+          <a:lstStyle/>
+          <a:p>
+            <a:pPr>
+              <a:lnSpc>
+                <a:spcPct val="100000"/>
+              </a:lnSpc>
+            </a:pPr>
+            <a:r>
               <a:rPr sz="1500" b="0">
                 <a:solidFill>
                   <a:srgbClr val="4A4F55"/>
                 </a:solidFill>
                 <a:latin typeface="Barlow"/>
               </a:rPr>
-              <a:t>github.com/vnmoorthy/precedent  ·  vnmoorthy.github.io/precedent</a:t>
+              <a:t>github.com/vnmoorthy/precedent</a:t>
             </a:r>
           </a:p>
         </p:txBody>
@@ -3649,7 +3712,7 @@
           </a:bodyPr>
           <a:lstStyle/>
           <a:p>
-            <a:pPr algn="l">
+            <a:pPr>
               <a:lnSpc>
                 <a:spcPct val="100000"/>
               </a:lnSpc>
@@ -3688,7 +3751,7 @@
           </a:bodyPr>
           <a:lstStyle/>
           <a:p>
-            <a:pPr algn="l">
+            <a:pPr>
               <a:lnSpc>
                 <a:spcPct val="115000"/>
               </a:lnSpc>
@@ -3728,7 +3791,7 @@
           </a:bodyPr>
           <a:lstStyle/>
           <a:p>
-            <a:pPr algn="l">
+            <a:pPr>
               <a:lnSpc>
                 <a:spcPct val="100000"/>
               </a:lnSpc>
@@ -3767,7 +3830,7 @@
           </a:bodyPr>
           <a:lstStyle/>
           <a:p>
-            <a:pPr algn="l">
+            <a:pPr>
               <a:lnSpc>
                 <a:spcPct val="135000"/>
               </a:lnSpc>
@@ -3783,7 +3846,7 @@
             </a:r>
           </a:p>
           <a:p>
-            <a:pPr algn="l">
+            <a:pPr>
               <a:lnSpc>
                 <a:spcPct val="135000"/>
               </a:lnSpc>
@@ -3799,7 +3862,7 @@
             </a:r>
           </a:p>
           <a:p>
-            <a:pPr algn="l">
+            <a:pPr>
               <a:lnSpc>
                 <a:spcPct val="135000"/>
               </a:lnSpc>
@@ -3900,7 +3963,7 @@
           </a:bodyPr>
           <a:lstStyle/>
           <a:p>
-            <a:pPr algn="l">
+            <a:pPr>
               <a:lnSpc>
                 <a:spcPct val="100000"/>
               </a:lnSpc>
@@ -3939,7 +4002,7 @@
           </a:bodyPr>
           <a:lstStyle/>
           <a:p>
-            <a:pPr algn="l">
+            <a:pPr>
               <a:lnSpc>
                 <a:spcPct val="95000"/>
               </a:lnSpc>
@@ -3979,7 +4042,7 @@
           </a:bodyPr>
           <a:lstStyle/>
           <a:p>
-            <a:pPr algn="l">
+            <a:pPr>
               <a:lnSpc>
                 <a:spcPct val="135000"/>
               </a:lnSpc>
@@ -3995,7 +4058,7 @@
             </a:r>
           </a:p>
           <a:p>
-            <a:pPr algn="l">
+            <a:pPr>
               <a:lnSpc>
                 <a:spcPct val="135000"/>
               </a:lnSpc>
@@ -4011,7 +4074,7 @@
             </a:r>
           </a:p>
           <a:p>
-            <a:pPr algn="l">
+            <a:pPr>
               <a:lnSpc>
                 <a:spcPct val="135000"/>
               </a:lnSpc>
@@ -4112,7 +4175,7 @@
           </a:bodyPr>
           <a:lstStyle/>
           <a:p>
-            <a:pPr algn="l">
+            <a:pPr>
               <a:lnSpc>
                 <a:spcPct val="100000"/>
               </a:lnSpc>
@@ -4151,7 +4214,7 @@
           </a:bodyPr>
           <a:lstStyle/>
           <a:p>
-            <a:pPr algn="l">
+            <a:pPr>
               <a:lnSpc>
                 <a:spcPct val="95000"/>
               </a:lnSpc>
@@ -4190,7 +4253,7 @@
           </a:bodyPr>
           <a:lstStyle/>
           <a:p>
-            <a:pPr algn="l">
+            <a:pPr>
               <a:lnSpc>
                 <a:spcPct val="135000"/>
               </a:lnSpc>
@@ -4206,7 +4269,7 @@
             </a:r>
           </a:p>
           <a:p>
-            <a:pPr algn="l">
+            <a:pPr>
               <a:lnSpc>
                 <a:spcPct val="135000"/>
               </a:lnSpc>
@@ -4222,7 +4285,7 @@
             </a:r>
           </a:p>
           <a:p>
-            <a:pPr algn="l">
+            <a:pPr>
               <a:lnSpc>
                 <a:spcPct val="135000"/>
               </a:lnSpc>
@@ -4238,7 +4301,7 @@
             </a:r>
           </a:p>
           <a:p>
-            <a:pPr algn="l">
+            <a:pPr>
               <a:lnSpc>
                 <a:spcPct val="135000"/>
               </a:lnSpc>
@@ -4250,7 +4313,7 @@
                 </a:solidFill>
                 <a:latin typeface="Barlow"/>
               </a:rPr>
-              <a:t>—  The agent reads the denial and corrects itself — no human in the loop</a:t>
+              <a:t>—  The agent reads the denial and corrects itself — every governed write audited, allow and deny</a:t>
             </a:r>
           </a:p>
         </p:txBody>
@@ -4339,7 +4402,7 @@
           </a:bodyPr>
           <a:lstStyle/>
           <a:p>
-            <a:pPr algn="l">
+            <a:pPr>
               <a:lnSpc>
                 <a:spcPct val="100000"/>
               </a:lnSpc>
@@ -4351,7 +4414,7 @@
                 </a:solidFill>
                 <a:latin typeface="Barlow"/>
               </a:rPr>
-              <a:t>04 · CAPTURED LIVE · TODAY 16:10</a:t>
+              <a:t>04 · CAPTURED LIVE · TODAY</a:t>
             </a:r>
           </a:p>
         </p:txBody>
@@ -4364,8 +4427,8 @@
         </p:nvSpPr>
         <p:spPr>
           <a:xfrm>
-            <a:off x="822960" y="1371600"/>
-            <a:ext cx="10515600" cy="4480560"/>
+            <a:off x="822960" y="1280160"/>
+            <a:ext cx="5760720" cy="4846320"/>
           </a:xfrm>
           <a:prstGeom prst="rect">
             <a:avLst/>
@@ -4395,7 +4458,7 @@
           </a:fontRef>
         </p:style>
         <p:txBody>
-          <a:bodyPr rtlCol="0" anchor="ctr" wrap="square" lIns="320040" tIns="274320"/>
+          <a:bodyPr rtlCol="0" anchor="ctr" wrap="square" lIns="274320" tIns="228600"/>
           <a:lstStyle/>
           <a:p>
             <a:pPr algn="ctr">
@@ -4404,7 +4467,7 @@
               </a:lnSpc>
             </a:pPr>
             <a:r>
-              <a:rPr sz="1700" b="0">
+              <a:rPr sz="1500" b="0">
                 <a:solidFill>
                   <a:srgbClr val="4A4F55"/>
                 </a:solidFill>
@@ -4420,7 +4483,7 @@
               </a:lnSpc>
             </a:pPr>
             <a:r>
-              <a:rPr sz="1700" b="0">
+              <a:rPr sz="1500" b="0">
                 <a:solidFill>
                   <a:srgbClr val="9AA0A6"/>
                 </a:solidFill>
@@ -4436,13 +4499,13 @@
               </a:lnSpc>
             </a:pPr>
             <a:r>
-              <a:rPr sz="1700" b="1">
+              <a:rPr sz="1500" b="1">
                 <a:solidFill>
                   <a:srgbClr val="FF3B30"/>
                 </a:solidFill>
                 <a:latin typeface="Consolas"/>
               </a:rPr>
-              <a:t>DENIED — ruling #1: "Verify the webhook signature before parsing the body."</a:t>
+              <a:t>DENIED — ruling #1: verify the webhook signature</a:t>
             </a:r>
           </a:p>
           <a:p>
@@ -4452,13 +4515,13 @@
               </a:lnSpc>
             </a:pPr>
             <a:r>
-              <a:rPr sz="1700" b="0">
+              <a:rPr sz="1500" b="0">
                 <a:solidFill>
                   <a:srgbClr val="4A4F55"/>
                 </a:solidFill>
                 <a:latin typeface="Consolas"/>
               </a:rPr>
-              <a:t>First raised by @you in PR #388 · raised 4× · 1.1 ms</a:t>
+              <a:t>First raised in PR #388 · raised 4× · 1.1 ms</a:t>
             </a:r>
           </a:p>
           <a:p>
@@ -4468,7 +4531,7 @@
               </a:lnSpc>
             </a:pPr>
             <a:r>
-              <a:rPr sz="1700" b="0">
+              <a:rPr sz="1500" b="0">
                 <a:solidFill>
                   <a:srgbClr val="9AA0A6"/>
                 </a:solidFill>
@@ -4484,7 +4547,7 @@
               </a:lnSpc>
             </a:pPr>
             <a:r>
-              <a:rPr sz="1700" b="0">
+              <a:rPr sz="1500" b="0">
                 <a:solidFill>
                   <a:srgbClr val="4A4F55"/>
                 </a:solidFill>
@@ -4500,13 +4563,13 @@
               </a:lnSpc>
             </a:pPr>
             <a:r>
-              <a:rPr sz="1700" b="1">
+              <a:rPr sz="1500" b="1">
                 <a:solidFill>
                   <a:srgbClr val="30D158"/>
                 </a:solidFill>
                 <a:latin typeface="Consolas"/>
               </a:rPr>
-              <a:t>ALLOWED — crypto.timingSafeEqual · deduped external_delivery_id</a:t>
+              <a:t>ALLOWED — crypto.timingSafeEqual ·</a:t>
             </a:r>
           </a:p>
           <a:p>
@@ -4516,13 +4579,92 @@
               </a:lnSpc>
             </a:pPr>
             <a:r>
-              <a:rPr sz="1700" b="0">
+              <a:rPr sz="1500" b="1">
                 <a:solidFill>
                   <a:srgbClr val="30D158"/>
                 </a:solidFill>
                 <a:latin typeface="Consolas"/>
               </a:rPr>
+              <a:t>deduped external_delivery_id</a:t>
+            </a:r>
+          </a:p>
+          <a:p>
+            <a:pPr>
+              <a:lnSpc>
+                <a:spcPct val="130000"/>
+              </a:lnSpc>
+            </a:pPr>
+            <a:r>
+              <a:rPr sz="1500" b="0">
+                <a:solidFill>
+                  <a:srgbClr val="30D158"/>
+                </a:solidFill>
+                <a:latin typeface="Consolas"/>
+              </a:rPr>
               <a:t>✓ bun test — pass</a:t>
+            </a:r>
+          </a:p>
+        </p:txBody>
+      </p:sp>
+      <p:pic>
+        <p:nvPicPr>
+          <p:cNvPr id="5" name="Picture 4" descr="demo.png"/>
+          <p:cNvPicPr>
+            <a:picLocks noChangeAspect="1"/>
+          </p:cNvPicPr>
+          <p:nvPr/>
+        </p:nvPicPr>
+        <p:blipFill>
+          <a:blip r:embed="rId2"/>
+          <a:stretch>
+            <a:fillRect/>
+          </a:stretch>
+        </p:blipFill>
+        <p:spPr>
+          <a:xfrm>
+            <a:off x="6858000" y="1280160"/>
+            <a:ext cx="4572000" cy="2857500"/>
+          </a:xfrm>
+          <a:prstGeom prst="rect">
+            <a:avLst/>
+          </a:prstGeom>
+        </p:spPr>
+      </p:pic>
+      <p:sp>
+        <p:nvSpPr>
+          <p:cNvPr id="6" name="TextBox 5"/>
+          <p:cNvSpPr txBox="1"/>
+          <p:nvPr/>
+        </p:nvSpPr>
+        <p:spPr>
+          <a:xfrm>
+            <a:off x="6858000" y="4192524"/>
+            <a:ext cx="4572000" cy="365760"/>
+          </a:xfrm>
+          <a:prstGeom prst="rect">
+            <a:avLst/>
+          </a:prstGeom>
+          <a:noFill/>
+        </p:spPr>
+        <p:txBody>
+          <a:bodyPr wrap="square">
+            <a:spAutoFit/>
+          </a:bodyPr>
+          <a:lstStyle/>
+          <a:p>
+            <a:pPr>
+              <a:lnSpc>
+                <a:spcPct val="100000"/>
+              </a:lnSpc>
+            </a:pPr>
+            <a:r>
+              <a:rPr sz="1100" b="0">
+                <a:solidFill>
+                  <a:srgbClr val="4A4F55"/>
+                </a:solidFill>
+                <a:latin typeface="Barlow"/>
+              </a:rPr>
+              <a:t>vnmoorthy.github.io/precedent/demo — interactive replay</a:t>
             </a:r>
           </a:p>
         </p:txBody>
@@ -4611,7 +4753,7 @@
           </a:bodyPr>
           <a:lstStyle/>
           <a:p>
-            <a:pPr algn="l">
+            <a:pPr>
               <a:lnSpc>
                 <a:spcPct val="100000"/>
               </a:lnSpc>
@@ -4650,7 +4792,7 @@
           </a:bodyPr>
           <a:lstStyle/>
           <a:p>
-            <a:pPr algn="l">
+            <a:pPr>
               <a:lnSpc>
                 <a:spcPct val="95000"/>
               </a:lnSpc>
@@ -4896,7 +5038,7 @@
           </a:bodyPr>
           <a:lstStyle/>
           <a:p>
-            <a:pPr algn="l">
+            <a:pPr>
               <a:lnSpc>
                 <a:spcPct val="100000"/>
               </a:lnSpc>
@@ -4997,7 +5139,7 @@
           </a:bodyPr>
           <a:lstStyle/>
           <a:p>
-            <a:pPr algn="l">
+            <a:pPr>
               <a:lnSpc>
                 <a:spcPct val="100000"/>
               </a:lnSpc>
@@ -5036,7 +5178,7 @@
           </a:bodyPr>
           <a:lstStyle/>
           <a:p>
-            <a:pPr algn="l">
+            <a:pPr>
               <a:lnSpc>
                 <a:spcPct val="95000"/>
               </a:lnSpc>
@@ -5075,7 +5217,7 @@
           </a:bodyPr>
           <a:lstStyle/>
           <a:p>
-            <a:pPr algn="l">
+            <a:pPr>
               <a:lnSpc>
                 <a:spcPct val="135000"/>
               </a:lnSpc>
@@ -5091,7 +5233,7 @@
             </a:r>
           </a:p>
           <a:p>
-            <a:pPr algn="l">
+            <a:pPr>
               <a:lnSpc>
                 <a:spcPct val="135000"/>
               </a:lnSpc>
@@ -5107,7 +5249,7 @@
             </a:r>
           </a:p>
           <a:p>
-            <a:pPr algn="l">
+            <a:pPr>
               <a:lnSpc>
                 <a:spcPct val="135000"/>
               </a:lnSpc>
@@ -5123,7 +5265,7 @@
             </a:r>
           </a:p>
           <a:p>
-            <a:pPr algn="l">
+            <a:pPr>
               <a:lnSpc>
                 <a:spcPct val="135000"/>
               </a:lnSpc>
@@ -5135,11 +5277,11 @@
                 </a:solidFill>
                 <a:latin typeface="Barlow"/>
               </a:rPr>
-              <a:t>—  Hardened to qualified-call rulings → same task, 0 → 9 denials</a:t>
-            </a:r>
-          </a:p>
-          <a:p>
-            <a:pPr algn="l">
+              <a:t>—  Greptile's reviewer then found an addition-only hunk bypass — both layers closed the same hour</a:t>
+            </a:r>
+          </a:p>
+          <a:p>
+            <a:pPr>
               <a:lnSpc>
                 <a:spcPct val="135000"/>
               </a:lnSpc>
@@ -5151,7 +5293,7 @@
                 </a:solidFill>
                 <a:latin typeface="Barlow"/>
               </a:rPr>
-              <a:t>—  Today, Greptile's reviewer independently found the same decoy class in our ruleset — fixed within minutes</a:t>
+              <a:t>—  Every attack made the gate stronger — the build log is the receipt</a:t>
             </a:r>
           </a:p>
         </p:txBody>
@@ -5240,7 +5382,7 @@
           </a:bodyPr>
           <a:lstStyle/>
           <a:p>
-            <a:pPr algn="l">
+            <a:pPr>
               <a:lnSpc>
                 <a:spcPct val="100000"/>
               </a:lnSpc>
@@ -5252,21 +5394,45 @@
                 </a:solidFill>
                 <a:latin typeface="Barlow"/>
               </a:rPr>
-              <a:t>07 · TELEMETRY · ALL VERIFIED TODAY</a:t>
-            </a:r>
-          </a:p>
-        </p:txBody>
-      </p:sp>
-      <p:sp>
-        <p:nvSpPr>
-          <p:cNvPr id="4" name="TextBox 3"/>
+              <a:t>07 · THE LIVE BOARD · REAL SESSION DATA</a:t>
+            </a:r>
+          </a:p>
+        </p:txBody>
+      </p:sp>
+      <p:pic>
+        <p:nvPicPr>
+          <p:cNvPr id="4" name="Picture 3" descr="board.png"/>
+          <p:cNvPicPr>
+            <a:picLocks noChangeAspect="1"/>
+          </p:cNvPicPr>
+          <p:nvPr/>
+        </p:nvPicPr>
+        <p:blipFill>
+          <a:blip r:embed="rId2"/>
+          <a:stretch>
+            <a:fillRect/>
+          </a:stretch>
+        </p:blipFill>
+        <p:spPr>
+          <a:xfrm>
+            <a:off x="822960" y="1234440"/>
+            <a:ext cx="8412480" cy="5257800"/>
+          </a:xfrm>
+          <a:prstGeom prst="rect">
+            <a:avLst/>
+          </a:prstGeom>
+        </p:spPr>
+      </p:pic>
+      <p:sp>
+        <p:nvSpPr>
+          <p:cNvPr id="5" name="TextBox 4"/>
           <p:cNvSpPr txBox="1"/>
           <p:nvPr/>
         </p:nvSpPr>
         <p:spPr>
           <a:xfrm>
-            <a:off x="822960" y="2103120"/>
-            <a:ext cx="2651760" cy="1097280"/>
+            <a:off x="9509760" y="1371600"/>
+            <a:ext cx="2377440" cy="4572000"/>
           </a:xfrm>
           <a:prstGeom prst="rect">
             <a:avLst/>
@@ -5279,363 +5445,83 @@
           </a:bodyPr>
           <a:lstStyle/>
           <a:p>
-            <a:pPr algn="l">
-              <a:lnSpc>
-                <a:spcPct val="100000"/>
-              </a:lnSpc>
-            </a:pPr>
-            <a:r>
-              <a:rPr sz="4400" b="1">
-                <a:solidFill>
-                  <a:srgbClr val="FF3B30"/>
+            <a:pPr>
+              <a:lnSpc>
+                <a:spcPct val="160000"/>
+              </a:lnSpc>
+            </a:pPr>
+            <a:r>
+              <a:rPr sz="1700" b="1">
+                <a:solidFill>
+                  <a:srgbClr val="FFFFFF"/>
                 </a:solidFill>
                 <a:latin typeface="Barlow"/>
               </a:rPr>
-              <a:t>17+</a:t>
-            </a:r>
-          </a:p>
-        </p:txBody>
-      </p:sp>
-      <p:sp>
-        <p:nvSpPr>
-          <p:cNvPr id="5" name="TextBox 4"/>
-          <p:cNvSpPr txBox="1"/>
-          <p:nvPr/>
-        </p:nvSpPr>
-        <p:spPr>
-          <a:xfrm>
-            <a:off x="822960" y="3108960"/>
-            <a:ext cx="2651760" cy="457200"/>
-          </a:xfrm>
-          <a:prstGeom prst="rect">
-            <a:avLst/>
-          </a:prstGeom>
-          <a:noFill/>
-        </p:spPr>
-        <p:txBody>
-          <a:bodyPr wrap="square">
-            <a:spAutoFit/>
-          </a:bodyPr>
-          <a:lstStyle/>
-          <a:p>
-            <a:pPr algn="l">
-              <a:lnSpc>
-                <a:spcPct val="100000"/>
-              </a:lnSpc>
-            </a:pPr>
-            <a:r>
-              <a:rPr sz="1300" b="1">
-                <a:solidFill>
-                  <a:srgbClr val="9AA0A6"/>
+              <a:t>6+ denials</a:t>
+            </a:r>
+          </a:p>
+          <a:p>
+            <a:pPr>
+              <a:lnSpc>
+                <a:spcPct val="160000"/>
+              </a:lnSpc>
+            </a:pPr>
+            <a:r>
+              <a:rPr sz="1700" b="1">
+                <a:solidFill>
+                  <a:srgbClr val="FFFFFF"/>
                 </a:solidFill>
                 <a:latin typeface="Barlow"/>
               </a:rPr>
-              <a:t>DENIALS LOGGED</a:t>
-            </a:r>
-          </a:p>
-        </p:txBody>
-      </p:sp>
-      <p:sp>
-        <p:nvSpPr>
-          <p:cNvPr id="6" name="TextBox 5"/>
-          <p:cNvSpPr txBox="1"/>
-          <p:nvPr/>
-        </p:nvSpPr>
-        <p:spPr>
-          <a:xfrm>
-            <a:off x="3611879" y="2103120"/>
-            <a:ext cx="2651760" cy="1097280"/>
-          </a:xfrm>
-          <a:prstGeom prst="rect">
-            <a:avLst/>
-          </a:prstGeom>
-          <a:noFill/>
-        </p:spPr>
-        <p:txBody>
-          <a:bodyPr wrap="square">
-            <a:spAutoFit/>
-          </a:bodyPr>
-          <a:lstStyle/>
-          <a:p>
-            <a:pPr algn="l">
-              <a:lnSpc>
-                <a:spcPct val="100000"/>
-              </a:lnSpc>
-            </a:pPr>
-            <a:r>
-              <a:rPr sz="4400" b="1">
+              <a:t>$360 reclaimed</a:t>
+            </a:r>
+          </a:p>
+          <a:p>
+            <a:pPr>
+              <a:lnSpc>
+                <a:spcPct val="160000"/>
+              </a:lnSpc>
+            </a:pPr>
+            <a:r>
+              <a:rPr sz="1700" b="1">
                 <a:solidFill>
                   <a:srgbClr val="FFFFFF"/>
                 </a:solidFill>
                 <a:latin typeface="Barlow"/>
               </a:rPr>
-              <a:t>0.1ms</a:t>
-            </a:r>
-          </a:p>
-        </p:txBody>
-      </p:sp>
-      <p:sp>
-        <p:nvSpPr>
-          <p:cNvPr id="7" name="TextBox 6"/>
-          <p:cNvSpPr txBox="1"/>
-          <p:nvPr/>
-        </p:nvSpPr>
-        <p:spPr>
-          <a:xfrm>
-            <a:off x="3611879" y="3108960"/>
-            <a:ext cx="2651760" cy="457200"/>
-          </a:xfrm>
-          <a:prstGeom prst="rect">
-            <a:avLst/>
-          </a:prstGeom>
-          <a:noFill/>
-        </p:spPr>
-        <p:txBody>
-          <a:bodyPr wrap="square">
-            <a:spAutoFit/>
-          </a:bodyPr>
-          <a:lstStyle/>
-          <a:p>
-            <a:pPr algn="l">
-              <a:lnSpc>
-                <a:spcPct val="100000"/>
-              </a:lnSpc>
-            </a:pPr>
-            <a:r>
-              <a:rPr sz="1300" b="1">
-                <a:solidFill>
-                  <a:srgbClr val="9AA0A6"/>
+              <a:t>1.8 ms median</a:t>
+            </a:r>
+          </a:p>
+          <a:p>
+            <a:pPr>
+              <a:lnSpc>
+                <a:spcPct val="160000"/>
+              </a:lnSpc>
+            </a:pPr>
+            <a:r>
+              <a:rPr sz="1700" b="1">
+                <a:solidFill>
+                  <a:srgbClr val="FFFFFF"/>
                 </a:solidFill>
                 <a:latin typeface="Barlow"/>
               </a:rPr>
-              <a:t>FASTEST DECISION</a:t>
-            </a:r>
-          </a:p>
-        </p:txBody>
-      </p:sp>
-      <p:sp>
-        <p:nvSpPr>
-          <p:cNvPr id="8" name="TextBox 7"/>
-          <p:cNvSpPr txBox="1"/>
-          <p:nvPr/>
-        </p:nvSpPr>
-        <p:spPr>
-          <a:xfrm>
-            <a:off x="6400800" y="2103120"/>
-            <a:ext cx="2651760" cy="1097280"/>
-          </a:xfrm>
-          <a:prstGeom prst="rect">
-            <a:avLst/>
-          </a:prstGeom>
-          <a:noFill/>
-        </p:spPr>
-        <p:txBody>
-          <a:bodyPr wrap="square">
-            <a:spAutoFit/>
-          </a:bodyPr>
-          <a:lstStyle/>
-          <a:p>
-            <a:pPr algn="l">
-              <a:lnSpc>
-                <a:spcPct val="100000"/>
-              </a:lnSpc>
-            </a:pPr>
-            <a:r>
-              <a:rPr sz="4400" b="1">
-                <a:solidFill>
-                  <a:srgbClr val="30D158"/>
+              <a:t>every write audited</a:t>
+            </a:r>
+          </a:p>
+          <a:p>
+            <a:pPr>
+              <a:lnSpc>
+                <a:spcPct val="160000"/>
+              </a:lnSpc>
+            </a:pPr>
+            <a:r>
+              <a:rPr sz="1700" b="1">
+                <a:solidFill>
+                  <a:srgbClr val="FFFFFF"/>
                 </a:solidFill>
                 <a:latin typeface="Barlow"/>
               </a:rPr>
-              <a:t>16/16</a:t>
-            </a:r>
-          </a:p>
-        </p:txBody>
-      </p:sp>
-      <p:sp>
-        <p:nvSpPr>
-          <p:cNvPr id="9" name="TextBox 8"/>
-          <p:cNvSpPr txBox="1"/>
-          <p:nvPr/>
-        </p:nvSpPr>
-        <p:spPr>
-          <a:xfrm>
-            <a:off x="6400800" y="3108960"/>
-            <a:ext cx="2651760" cy="457200"/>
-          </a:xfrm>
-          <a:prstGeom prst="rect">
-            <a:avLst/>
-          </a:prstGeom>
-          <a:noFill/>
-        </p:spPr>
-        <p:txBody>
-          <a:bodyPr wrap="square">
-            <a:spAutoFit/>
-          </a:bodyPr>
-          <a:lstStyle/>
-          <a:p>
-            <a:pPr algn="l">
-              <a:lnSpc>
-                <a:spcPct val="100000"/>
-              </a:lnSpc>
-            </a:pPr>
-            <a:r>
-              <a:rPr sz="1300" b="1">
-                <a:solidFill>
-                  <a:srgbClr val="9AA0A6"/>
-                </a:solidFill>
-                <a:latin typeface="Barlow"/>
-              </a:rPr>
-              <a:t>TESTS PASSING</a:t>
-            </a:r>
-          </a:p>
-        </p:txBody>
-      </p:sp>
-      <p:sp>
-        <p:nvSpPr>
-          <p:cNvPr id="10" name="TextBox 9"/>
-          <p:cNvSpPr txBox="1"/>
-          <p:nvPr/>
-        </p:nvSpPr>
-        <p:spPr>
-          <a:xfrm>
-            <a:off x="9189719" y="2103120"/>
-            <a:ext cx="2651760" cy="1097280"/>
-          </a:xfrm>
-          <a:prstGeom prst="rect">
-            <a:avLst/>
-          </a:prstGeom>
-          <a:noFill/>
-        </p:spPr>
-        <p:txBody>
-          <a:bodyPr wrap="square">
-            <a:spAutoFit/>
-          </a:bodyPr>
-          <a:lstStyle/>
-          <a:p>
-            <a:pPr algn="l">
-              <a:lnSpc>
-                <a:spcPct val="100000"/>
-              </a:lnSpc>
-            </a:pPr>
-            <a:r>
-              <a:rPr sz="4400" b="1">
-                <a:solidFill>
-                  <a:srgbClr val="FFFFFF"/>
-                </a:solidFill>
-                <a:latin typeface="Barlow"/>
-              </a:rPr>
-              <a:t>2</a:t>
-            </a:r>
-          </a:p>
-        </p:txBody>
-      </p:sp>
-      <p:sp>
-        <p:nvSpPr>
-          <p:cNvPr id="11" name="TextBox 10"/>
-          <p:cNvSpPr txBox="1"/>
-          <p:nvPr/>
-        </p:nvSpPr>
-        <p:spPr>
-          <a:xfrm>
-            <a:off x="9189719" y="3108960"/>
-            <a:ext cx="2651760" cy="457200"/>
-          </a:xfrm>
-          <a:prstGeom prst="rect">
-            <a:avLst/>
-          </a:prstGeom>
-          <a:noFill/>
-        </p:spPr>
-        <p:txBody>
-          <a:bodyPr wrap="square">
-            <a:spAutoFit/>
-          </a:bodyPr>
-          <a:lstStyle/>
-          <a:p>
-            <a:pPr algn="l">
-              <a:lnSpc>
-                <a:spcPct val="100000"/>
-              </a:lnSpc>
-            </a:pPr>
-            <a:r>
-              <a:rPr sz="1300" b="1">
-                <a:solidFill>
-                  <a:srgbClr val="9AA0A6"/>
-                </a:solidFill>
-                <a:latin typeface="Barlow"/>
-              </a:rPr>
-              <a:t>RULINGS IN MEMORY</a:t>
-            </a:r>
-          </a:p>
-        </p:txBody>
-      </p:sp>
-      <p:sp>
-        <p:nvSpPr>
-          <p:cNvPr id="12" name="TextBox 11"/>
-          <p:cNvSpPr txBox="1"/>
-          <p:nvPr/>
-        </p:nvSpPr>
-        <p:spPr>
-          <a:xfrm>
-            <a:off x="822960" y="4206240"/>
-            <a:ext cx="10515600" cy="3200400"/>
-          </a:xfrm>
-          <a:prstGeom prst="rect">
-            <a:avLst/>
-          </a:prstGeom>
-          <a:noFill/>
-        </p:spPr>
-        <p:txBody>
-          <a:bodyPr wrap="square">
-            <a:spAutoFit/>
-          </a:bodyPr>
-          <a:lstStyle/>
-          <a:p>
-            <a:pPr algn="l">
-              <a:lnSpc>
-                <a:spcPct val="135000"/>
-              </a:lnSpc>
-            </a:pPr>
-            <a:r>
-              <a:rPr sz="1900" b="0">
-                <a:solidFill>
-                  <a:srgbClr val="9AA0A6"/>
-                </a:solidFill>
-                <a:latin typeface="Barlow"/>
-              </a:rPr>
-              <a:t>—  Value ledger on the live board: each denial ≈ one prevented repeat-review round ≈ 30 reviewer-minutes ≈ $60</a:t>
-            </a:r>
-          </a:p>
-          <a:p>
-            <a:pPr algn="l">
-              <a:lnSpc>
-                <a:spcPct val="135000"/>
-              </a:lnSpc>
-            </a:pPr>
-            <a:r>
-              <a:rPr sz="1900" b="0">
-                <a:solidFill>
-                  <a:srgbClr val="9AA0A6"/>
-                </a:solidFill>
-                <a:latin typeface="Barlow"/>
-              </a:rPr>
-              <a:t>—  Fails open — a dead daemon never blocks the agent</a:t>
-            </a:r>
-          </a:p>
-          <a:p>
-            <a:pPr algn="l">
-              <a:lnSpc>
-                <a:spcPct val="135000"/>
-              </a:lnSpc>
-            </a:pPr>
-            <a:r>
-              <a:rPr sz="1900" b="0">
-                <a:solidFill>
-                  <a:srgbClr val="9AA0A6"/>
-                </a:solidFill>
-                <a:latin typeface="Barlow"/>
-              </a:rPr>
-              <a:t>—  One-command install: precedent init &lt;repo&gt; — verified on a fresh client repo</a:t>
+              <a:t>16/16 tests</a:t>
             </a:r>
           </a:p>
         </p:txBody>
@@ -5724,7 +5610,7 @@
           </a:bodyPr>
           <a:lstStyle/>
           <a:p>
-            <a:pPr algn="l">
+            <a:pPr>
               <a:lnSpc>
                 <a:spcPct val="100000"/>
               </a:lnSpc>
@@ -5763,7 +5649,7 @@
           </a:bodyPr>
           <a:lstStyle/>
           <a:p>
-            <a:pPr algn="l">
+            <a:pPr>
               <a:lnSpc>
                 <a:spcPct val="100000"/>
               </a:lnSpc>
@@ -5802,7 +5688,7 @@
           </a:bodyPr>
           <a:lstStyle/>
           <a:p>
-            <a:pPr algn="l">
+            <a:pPr>
               <a:lnSpc>
                 <a:spcPct val="130000"/>
               </a:lnSpc>
@@ -5818,7 +5704,7 @@
             </a:r>
           </a:p>
           <a:p>
-            <a:pPr algn="l">
+            <a:pPr>
               <a:lnSpc>
                 <a:spcPct val="130000"/>
               </a:lnSpc>
@@ -5834,7 +5720,7 @@
             </a:r>
           </a:p>
           <a:p>
-            <a:pPr algn="l">
+            <a:pPr>
               <a:lnSpc>
                 <a:spcPct val="130000"/>
               </a:lnSpc>
@@ -5873,7 +5759,7 @@
           </a:bodyPr>
           <a:lstStyle/>
           <a:p>
-            <a:pPr algn="l">
+            <a:pPr>
               <a:lnSpc>
                 <a:spcPct val="100000"/>
               </a:lnSpc>
@@ -5912,7 +5798,7 @@
           </a:bodyPr>
           <a:lstStyle/>
           <a:p>
-            <a:pPr algn="l">
+            <a:pPr>
               <a:lnSpc>
                 <a:spcPct val="130000"/>
               </a:lnSpc>
@@ -5928,7 +5814,7 @@
             </a:r>
           </a:p>
           <a:p>
-            <a:pPr algn="l">
+            <a:pPr>
               <a:lnSpc>
                 <a:spcPct val="130000"/>
               </a:lnSpc>
@@ -5940,11 +5826,11 @@
                 </a:solidFill>
                 <a:latin typeface="Barlow"/>
               </a:rPr>
-              <a:t>—  Greptile — enabled on the repo; reviewed the product live (3 P1s → fixed)</a:t>
-            </a:r>
-          </a:p>
-          <a:p>
-            <a:pPr algn="l">
+              <a:t>—  Greptile — enabled on the repo; reviewed the product live (P1s → fixed)</a:t>
+            </a:r>
+          </a:p>
+          <a:p>
+            <a:pPr>
               <a:lnSpc>
                 <a:spcPct val="130000"/>
               </a:lnSpc>
@@ -5960,7 +5846,7 @@
             </a:r>
           </a:p>
           <a:p>
-            <a:pPr algn="l">
+            <a:pPr>
               <a:lnSpc>
                 <a:spcPct val="130000"/>
               </a:lnSpc>
@@ -5976,7 +5862,7 @@
             </a:r>
           </a:p>
           <a:p>
-            <a:pPr algn="l">
+            <a:pPr>
               <a:lnSpc>
                 <a:spcPct val="130000"/>
               </a:lnSpc>
@@ -5992,7 +5878,7 @@
             </a:r>
           </a:p>
           <a:p>
-            <a:pPr algn="l">
+            <a:pPr>
               <a:lnSpc>
                 <a:spcPct val="130000"/>
               </a:lnSpc>

</xml_diff>